<commit_message>
Actualiza entrega: solo enlaces de la culminacion
Co-authored-by: Cursor <cursoragent@cursor.com>
</commit_message>
<xml_diff>
--- a/docs/PRESENTACION-RestoBook-EVA.pptx
+++ b/docs/PRESENTACION-RestoBook-EVA.pptx
@@ -3074,7 +3074,7 @@
                 <a:ea typeface="Arial" pitchFamily="34" charset="-122"/>
                 <a:cs typeface="Arial" pitchFamily="34" charset="-120"/>
               </a:rPr>
-              <a:t>Ciclo 1 (parcial): 4.2/5  →  Ciclo 2 (final): 4.6/5</a:t>
+              <a:t>Ciclo 1: 4.2/5  →  Culminación: 4.6/5</a:t>
             </a:r>
             <a:endParaRPr lang="en-US" sz="1600" dirty="0"/>
           </a:p>
@@ -3517,7 +3517,7 @@
                 <a:ea typeface="Arial" pitchFamily="34" charset="-122"/>
                 <a:cs typeface="Arial" pitchFamily="34" charset="-120"/>
               </a:rPr>
-              <a:t>•  El final continúa el parcial EPD con evidencia de iteración UX</a:t>
+              <a:t>•  Culminación con evidencia de iteración UX</a:t>
             </a:r>
             <a:endParaRPr lang="en-US" sz="1600" dirty="0"/>
           </a:p>

</xml_diff>